<commit_message>
Align KIT docs with paired development results
</commit_message>
<xml_diff>
--- a/docs/slides/battery-early-warning-research-seminar-kit-b-vs-dcore-development-oof.pptx
+++ b/docs/slides/battery-early-warning-research-seminar-kit-b-vs-dcore-development-oof.pptx
@@ -1362,7 +1362,7 @@
           <a:lstStyle/>
           <a:p>
             <a:r>
-              <a:t>下一步不是盲目增加神经网络。先解释失败模式，再检验 EIS 是否真正增加信息，最后才讨论选择、 告警和部署。</a:t>
+              <a:t>下一步不是盲目增加神经网络。配对 B/D_CORE 开发比较已经完成；现在先解释为什么不同 mode 和 model family 给出相反方向，再决定是否值得进入选择、protected test、告警或部署研究。</a:t>
             </a:r>
           </a:p>
         </p:txBody>
@@ -1432,7 +1432,7 @@
           <a:lstStyle/>
           <a:p>
             <a:r>
-              <a:t>项目现在已经从“纸上计划”进入了真实训练和可审计结果阶段，但还没有跨过最终验证边界。下一轮 工作的重点是解释模式差异、加入严格配对的 EIS 对照，并保留 protected test。</a:t>
+              <a:t>项目已经完成严格配对的 B/D_CORE development OOF，但还没有跨过最终验证边界。下一轮重点是 解释 mode × family 差异和特征稳定性；在冻结新协议并独立批准前，不打开 protected test。</a:t>
             </a:r>
           </a:p>
         </p:txBody>
@@ -25457,7 +25457,7 @@
               </a:defRPr>
             </a:pPr>
             <a:r>
-              <a:t>EIS incremental</a:t>
+              <a:t>解释 EIS 增量</a:t>
             </a:r>
           </a:p>
         </p:txBody>
@@ -25496,7 +25496,7 @@
               </a:defRPr>
             </a:pPr>
             <a:r>
-              <a:t>同 snapshot / fold / model 比 B vs D_CORE</a:t>
+              <a:t>分析 mode × family、共线性与稳定性</a:t>
             </a:r>
           </a:p>
         </p:txBody>
@@ -26201,7 +26201,7 @@
               </a:defRPr>
             </a:pPr>
             <a:r>
-              <a:t>先解释失败模式，再检验 EIS 增量，最后讨论选择、告警与部署。</a:t>
+              <a:t>配对 EIS 比较已完成；先解释相反方向，再讨论选择、告警与部署。</a:t>
             </a:r>
           </a:p>
         </p:txBody>
@@ -27416,7 +27416,7 @@
               </a:defRPr>
             </a:pPr>
             <a:r>
-              <a:t>EIS replication</a:t>
+              <a:t>EIS 通用 / 因果结论</a:t>
             </a:r>
           </a:p>
         </p:txBody>

</xml_diff>